<commit_message>
Playright and UI revamp
</commit_message>
<xml_diff>
--- a/UniServe_Pitch_v3.pptx
+++ b/UniServe_Pitch_v3.pptx
@@ -3051,6 +3051,9 @@
   <p:sldLayoutIdLst>
     <p:sldLayoutId id="2147483649" r:id="rId1"/>
   </p:sldLayoutIdLst>
+  <p:transition spd="med">
+    <p:push dir="r"/>
+  </p:transition>
   <p:hf dt="0" ftr="0" hdr="0" sldNum="0"/>
   <p:txStyles>
     <p:titleStyle>
@@ -5312,6 +5315,18 @@
   <p:clrMapOvr>
     <a:masterClrMapping/>
   </p:clrMapOvr>
+  <mc:AlternateContent>
+    <mc:Choice Requires="p14">
+      <p:transition spd="med">
+        <p14:flip dir="l"/>
+      </p:transition>
+    </mc:Choice>
+    <mc:Fallback>
+      <p:transition spd="med">
+        <p:fade/>
+      </p:transition>
+    </mc:Fallback>
+  </mc:AlternateContent>
 </p:sld>
 </file>
 
@@ -8077,6 +8092,9 @@
   <p:clrMapOvr>
     <a:masterClrMapping/>
   </p:clrMapOvr>
+  <p:transition spd="med">
+    <p:push/>
+  </p:transition>
 </p:sld>
 </file>
 
@@ -23005,6 +23023,18 @@
   <p:clrMapOvr>
     <a:masterClrMapping/>
   </p:clrMapOvr>
+  <mc:AlternateContent>
+    <mc:Choice Requires="p14">
+      <p:transition spd="med">
+        <p14:flip dir="l"/>
+      </p:transition>
+    </mc:Choice>
+    <mc:Fallback>
+      <p:transition spd="med">
+        <p:fade/>
+      </p:transition>
+    </mc:Fallback>
+  </mc:AlternateContent>
 </p:sld>
 </file>
 

</xml_diff>